<commit_message>
changesd after KJD feedback, and with using storytelling with data skill
</commit_message>
<xml_diff>
--- a/storytelling/Wikipedia_25_Marcinos.pptx
+++ b/storytelling/Wikipedia_25_Marcinos.pptx
@@ -5,10 +5,10 @@
     <p:sldMasterId id="2147483648" r:id="rId1"/>
   </p:sldMasterIdLst>
   <p:notesMasterIdLst>
-    <p:notesMasterId r:id="rId14"/>
+    <p:notesMasterId r:id="rId15"/>
   </p:notesMasterIdLst>
   <p:handoutMasterIdLst>
-    <p:handoutMasterId r:id="rId15"/>
+    <p:handoutMasterId r:id="rId16"/>
   </p:handoutMasterIdLst>
   <p:sldIdLst>
     <p:sldId id="256" r:id="rId2"/>
@@ -20,9 +20,10 @@
     <p:sldId id="264" r:id="rId8"/>
     <p:sldId id="260" r:id="rId9"/>
     <p:sldId id="266" r:id="rId10"/>
-    <p:sldId id="267" r:id="rId11"/>
-    <p:sldId id="259" r:id="rId12"/>
-    <p:sldId id="265" r:id="rId13"/>
+    <p:sldId id="268" r:id="rId11"/>
+    <p:sldId id="267" r:id="rId12"/>
+    <p:sldId id="259" r:id="rId13"/>
+    <p:sldId id="265" r:id="rId14"/>
   </p:sldIdLst>
   <p:sldSz cx="12192000" cy="6858000"/>
   <p:notesSz cx="6858000" cy="9144000"/>
@@ -135,6 +136,7 @@
             <p14:sldId id="264"/>
             <p14:sldId id="260"/>
             <p14:sldId id="266"/>
+            <p14:sldId id="268"/>
             <p14:sldId id="267"/>
             <p14:sldId id="259"/>
             <p14:sldId id="265"/>
@@ -144,6 +146,9 @@
     </p:ext>
     <p:ext uri="{EFAFB233-063F-42B5-8137-9DF3F51BA10A}">
       <p15:sldGuideLst xmlns:p15="http://schemas.microsoft.com/office/powerpoint/2012/main"/>
+    </p:ext>
+    <p:ext uri="{2D200454-40CA-4A62-9FC3-DE9A4176ACB9}">
+      <p15:notesGuideLst xmlns:p15="http://schemas.microsoft.com/office/powerpoint/2012/main"/>
     </p:ext>
   </p:extLst>
 </p:presentation>
@@ -166,7 +171,7 @@
     <c:title>
       <c:tx>
         <c:rich>
-          <a:bodyPr rot="0" spcFirstLastPara="1" vertOverflow="ellipsis" wrap="square" anchor="t" anchorCtr="0"/>
+          <a:bodyPr rot="0" spcFirstLastPara="1" vertOverflow="ellipsis" vert="horz" wrap="square" anchor="t" anchorCtr="0"/>
           <a:lstStyle/>
           <a:p>
             <a:pPr algn="l">
@@ -211,7 +216,7 @@
         <a:effectLst/>
       </c:spPr>
       <c:txPr>
-        <a:bodyPr rot="0" spcFirstLastPara="1" vertOverflow="ellipsis" wrap="square" anchor="t" anchorCtr="0"/>
+        <a:bodyPr rot="0" spcFirstLastPara="1" vertOverflow="ellipsis" vert="horz" wrap="square" anchor="t" anchorCtr="0"/>
         <a:lstStyle/>
         <a:p>
           <a:pPr algn="l">
@@ -595,7 +600,7 @@
                   <a:schemeClr val="tx1"/>
                 </a:solidFill>
               </a:rPr>
-              <a:t>Suma wyświetleń w latach 2018 – 2026 [mln] [4]</a:t>
+              <a:t>Suma wyświetleń w latach 2018 – 2026 [mln]</a:t>
             </a:r>
             <a:endParaRPr lang="en-US" sz="1800" dirty="0">
               <a:solidFill>
@@ -961,7 +966,7 @@
           <c:showPercent val="0"/>
           <c:showBubbleSize val="0"/>
         </c:dLbls>
-        <c:gapWidth val="182"/>
+        <c:gapWidth val="120"/>
         <c:axId val="1154764064"/>
         <c:axId val="1813308464"/>
       </c:barChart>
@@ -1025,7 +1030,12 @@
         <c:majorGridlines>
           <c:spPr>
             <a:ln w="9525" cap="flat" cmpd="sng" algn="ctr">
-              <a:noFill/>
+              <a:solidFill>
+                <a:schemeClr val="accent6">
+                  <a:alpha val="50000"/>
+                </a:schemeClr>
+              </a:solidFill>
+              <a:prstDash val="sysDot"/>
               <a:round/>
             </a:ln>
             <a:effectLst/>
@@ -1186,15 +1196,7 @@
                   <a:schemeClr val="tx1"/>
                 </a:solidFill>
               </a:rPr>
-              <a:t> ruchu[mln] </a:t>
-            </a:r>
-            <a:r>
-              <a:rPr lang="pl-PL" sz="1800" dirty="0">
-                <a:solidFill>
-                  <a:schemeClr val="tx1"/>
-                </a:solidFill>
-              </a:rPr>
-              <a:t>[6]</a:t>
+              <a:t> ruchu[mln]</a:t>
             </a:r>
             <a:endParaRPr lang="en-US" sz="1800" dirty="0">
               <a:solidFill>
@@ -1676,7 +1678,7 @@
           <c:showPercent val="0"/>
           <c:showBubbleSize val="0"/>
         </c:dLbls>
-        <c:gapWidth val="219"/>
+        <c:gapWidth val="120"/>
         <c:axId val="287888656"/>
         <c:axId val="413498544"/>
       </c:barChart>
@@ -1735,6 +1737,20 @@
         </c:scaling>
         <c:delete val="0"/>
         <c:axPos val="b"/>
+        <c:majorGridlines>
+          <c:spPr>
+            <a:ln w="9525" cap="flat" cmpd="sng" algn="ctr">
+              <a:solidFill>
+                <a:schemeClr val="accent6">
+                  <a:alpha val="50000"/>
+                </a:schemeClr>
+              </a:solidFill>
+              <a:prstDash val="sysDot"/>
+              <a:round/>
+            </a:ln>
+            <a:effectLst/>
+          </c:spPr>
+        </c:majorGridlines>
         <c:numFmt formatCode="General" sourceLinked="1"/>
         <c:majorTickMark val="none"/>
         <c:minorTickMark val="none"/>
@@ -1849,7 +1865,10 @@
           <a:bodyPr rot="0" spcFirstLastPara="1" vertOverflow="ellipsis" vert="horz" wrap="square" anchor="ctr" anchorCtr="1"/>
           <a:lstStyle/>
           <a:p>
-            <a:pPr algn="l">
+            <a:pPr algn="l" defTabSz="927100">
+              <a:tabLst>
+                <a:tab pos="4124325" algn="l"/>
+              </a:tabLst>
               <a:defRPr sz="1862" b="0" i="0" u="none" strike="noStrike" kern="1200" spc="0" baseline="0">
                 <a:solidFill>
                   <a:schemeClr val="tx1"/>
@@ -1889,7 +1908,7 @@
                   <a:schemeClr val="tx1"/>
                 </a:solidFill>
               </a:rPr>
-              <a:t> [mln][4][8]</a:t>
+              <a:t> [mln]</a:t>
             </a:r>
             <a:endParaRPr lang="en-US" sz="1800" dirty="0">
               <a:solidFill>
@@ -1919,7 +1938,10 @@
         <a:bodyPr rot="0" spcFirstLastPara="1" vertOverflow="ellipsis" vert="horz" wrap="square" anchor="ctr" anchorCtr="1"/>
         <a:lstStyle/>
         <a:p>
-          <a:pPr algn="l">
+          <a:pPr algn="l" defTabSz="927100">
+            <a:tabLst>
+              <a:tab pos="4124325" algn="l"/>
+            </a:tabLst>
             <a:defRPr sz="1862" b="0" i="0" u="none" strike="noStrike" kern="1200" spc="0" baseline="0">
               <a:solidFill>
                 <a:schemeClr val="tx1"/>
@@ -3346,7 +3368,7 @@
                   <a:schemeClr val="tx1"/>
                 </a:solidFill>
               </a:rPr>
-              <a:t> [tys.][4]</a:t>
+              <a:t> [tys.]</a:t>
             </a:r>
             <a:endParaRPr lang="en-US" sz="1800" dirty="0">
               <a:solidFill>
@@ -3397,8 +3419,8 @@
           <c:layoutTarget val="inner"/>
           <c:xMode val="edge"/>
           <c:yMode val="edge"/>
-          <c:x val="5.3603301286851403E-2"/>
-          <c:y val="0.13158215048234079"/>
+          <c:x val="6.4278109814586426E-2"/>
+          <c:y val="0.12569330180558128"/>
           <c:w val="0.94418872912625051"/>
           <c:h val="0.75608435149749476"/>
         </c:manualLayout>
@@ -3432,6 +3454,721 @@
           <c:marker>
             <c:symbol val="none"/>
           </c:marker>
+          <c:dLbls>
+            <c:dLbl>
+              <c:idx val="33"/>
+              <c:layout>
+                <c:manualLayout>
+                  <c:x val="4.8192771084337352E-2"/>
+                  <c:y val="-7.5082820628683281E-2"/>
+                </c:manualLayout>
+              </c:layout>
+              <c:tx>
+                <c:rich>
+                  <a:bodyPr rot="0" spcFirstLastPara="1" vertOverflow="clip" horzOverflow="clip" vert="horz" wrap="square" lIns="38100" tIns="19050" rIns="38100" bIns="19050" anchor="ctr" anchorCtr="1">
+                    <a:noAutofit/>
+                  </a:bodyPr>
+                  <a:lstStyle/>
+                  <a:p>
+                    <a:pPr>
+                      <a:defRPr sz="1197" b="0" i="0" u="none" strike="noStrike" kern="1200" baseline="0">
+                        <a:solidFill>
+                          <a:schemeClr val="dk1">
+                            <a:lumMod val="65000"/>
+                            <a:lumOff val="35000"/>
+                          </a:schemeClr>
+                        </a:solidFill>
+                        <a:latin typeface="+mn-lt"/>
+                        <a:ea typeface="+mn-ea"/>
+                        <a:cs typeface="+mn-cs"/>
+                      </a:defRPr>
+                    </a:pPr>
+                    <a:r>
+                      <a:rPr lang="en-US" dirty="0" err="1"/>
+                      <a:t>Pierwsza</a:t>
+                    </a:r>
+                    <a:r>
+                      <a:rPr lang="en-US" dirty="0"/>
+                      <a:t> </a:t>
+                    </a:r>
+                    <a:r>
+                      <a:rPr lang="en-US" dirty="0" err="1"/>
+                      <a:t>wygrana</a:t>
+                    </a:r>
+                    <a:r>
+                      <a:rPr lang="en-US" dirty="0"/>
+                      <a:t> Rolanda Garrosa</a:t>
+                    </a:r>
+                  </a:p>
+                </c:rich>
+              </c:tx>
+              <c:spPr>
+                <a:solidFill>
+                  <a:prstClr val="white"/>
+                </a:solidFill>
+                <a:ln>
+                  <a:solidFill>
+                    <a:srgbClr val="000000">
+                      <a:lumMod val="25000"/>
+                      <a:lumOff val="75000"/>
+                    </a:srgbClr>
+                  </a:solidFill>
+                </a:ln>
+                <a:effectLst/>
+              </c:spPr>
+              <c:txPr>
+                <a:bodyPr rot="0" spcFirstLastPara="1" vertOverflow="clip" horzOverflow="clip" vert="horz" wrap="square" lIns="38100" tIns="19050" rIns="38100" bIns="19050" anchor="ctr" anchorCtr="1">
+                  <a:noAutofit/>
+                </a:bodyPr>
+                <a:lstStyle/>
+                <a:p>
+                  <a:pPr>
+                    <a:defRPr sz="1197" b="0" i="0" u="none" strike="noStrike" kern="1200" baseline="0">
+                      <a:solidFill>
+                        <a:schemeClr val="dk1">
+                          <a:lumMod val="65000"/>
+                          <a:lumOff val="35000"/>
+                        </a:schemeClr>
+                      </a:solidFill>
+                      <a:latin typeface="+mn-lt"/>
+                      <a:ea typeface="+mn-ea"/>
+                      <a:cs typeface="+mn-cs"/>
+                    </a:defRPr>
+                  </a:pPr>
+                  <a:endParaRPr lang="pl-PL"/>
+                </a:p>
+              </c:txPr>
+              <c:showLegendKey val="0"/>
+              <c:showVal val="1"/>
+              <c:showCatName val="1"/>
+              <c:showSerName val="0"/>
+              <c:showPercent val="0"/>
+              <c:showBubbleSize val="0"/>
+              <c:extLst>
+                <c:ext xmlns:c15="http://schemas.microsoft.com/office/drawing/2012/chart" uri="{CE6537A1-D6FC-4f65-9D91-7224C49458BB}">
+                  <c15:spPr xmlns:c15="http://schemas.microsoft.com/office/drawing/2012/chart">
+                    <a:prstGeom prst="wedgeRectCallout">
+                      <a:avLst/>
+                    </a:prstGeom>
+                    <a:noFill/>
+                    <a:ln>
+                      <a:noFill/>
+                    </a:ln>
+                  </c15:spPr>
+                  <c15:layout>
+                    <c:manualLayout>
+                      <c:w val="0.23830390679076763"/>
+                      <c:h val="0.11255583683437752"/>
+                    </c:manualLayout>
+                  </c15:layout>
+                  <c15:showDataLabelsRange val="0"/>
+                </c:ext>
+                <c:ext xmlns:c16="http://schemas.microsoft.com/office/drawing/2014/chart" uri="{C3380CC4-5D6E-409C-BE32-E72D297353CC}">
+                  <c16:uniqueId val="{00000001-0E4A-4E4E-B9CD-2ED98FD21E61}"/>
+                </c:ext>
+              </c:extLst>
+            </c:dLbl>
+            <c:dLbl>
+              <c:idx val="53"/>
+              <c:layout>
+                <c:manualLayout>
+                  <c:x val="-7.1396697902722656E-3"/>
+                  <c:y val="-0.15311006559574636"/>
+                </c:manualLayout>
+              </c:layout>
+              <c:tx>
+                <c:rich>
+                  <a:bodyPr rot="0" spcFirstLastPara="1" vertOverflow="clip" horzOverflow="clip" vert="horz" wrap="square" lIns="38100" tIns="19050" rIns="38100" bIns="19050" anchor="ctr" anchorCtr="0">
+                    <a:spAutoFit/>
+                  </a:bodyPr>
+                  <a:lstStyle/>
+                  <a:p>
+                    <a:pPr marL="0" marR="0" lvl="0" indent="0" algn="ctr" defTabSz="914400" rtl="0" eaLnBrk="1" fontAlgn="auto" latinLnBrk="0" hangingPunct="1">
+                      <a:lnSpc>
+                        <a:spcPct val="100000"/>
+                      </a:lnSpc>
+                      <a:spcBef>
+                        <a:spcPts val="0"/>
+                      </a:spcBef>
+                      <a:spcAft>
+                        <a:spcPts val="0"/>
+                      </a:spcAft>
+                      <a:buClrTx/>
+                      <a:buSzTx/>
+                      <a:buFontTx/>
+                      <a:buNone/>
+                      <a:tabLst/>
+                      <a:defRPr sz="1197" b="0" i="0" u="none" strike="noStrike" kern="1200" baseline="0">
+                        <a:solidFill>
+                          <a:srgbClr val="000000">
+                            <a:lumMod val="65000"/>
+                            <a:lumOff val="35000"/>
+                          </a:srgbClr>
+                        </a:solidFill>
+                        <a:latin typeface="+mn-lt"/>
+                        <a:ea typeface="+mn-ea"/>
+                        <a:cs typeface="+mn-cs"/>
+                      </a:defRPr>
+                    </a:pPr>
+                    <a:r>
+                      <a:rPr lang="en-US" sz="1197" b="0" i="0" u="none" strike="noStrike" kern="1200" baseline="0" dirty="0" err="1">
+                        <a:solidFill>
+                          <a:srgbClr val="000000">
+                            <a:lumMod val="65000"/>
+                            <a:lumOff val="35000"/>
+                          </a:srgbClr>
+                        </a:solidFill>
+                      </a:rPr>
+                      <a:t>Wygrana</a:t>
+                    </a:r>
+                    <a:r>
+                      <a:rPr lang="en-US" sz="1197" b="0" i="0" u="none" strike="noStrike" kern="1200" baseline="0" dirty="0">
+                        <a:solidFill>
+                          <a:srgbClr val="000000">
+                            <a:lumMod val="65000"/>
+                            <a:lumOff val="35000"/>
+                          </a:srgbClr>
+                        </a:solidFill>
+                      </a:rPr>
+                      <a:t> Rolanda </a:t>
+                    </a:r>
+                    <a:r>
+                      <a:rPr lang="en-US" sz="1197" b="0" i="0" u="none" strike="noStrike" kern="1200" baseline="0" dirty="0" err="1">
+                        <a:solidFill>
+                          <a:srgbClr val="000000">
+                            <a:lumMod val="65000"/>
+                            <a:lumOff val="35000"/>
+                          </a:srgbClr>
+                        </a:solidFill>
+                      </a:rPr>
+                      <a:t>Garrosa</a:t>
+                    </a:r>
+                    <a:endParaRPr lang="en-US" sz="1197" b="0" i="0" u="none" strike="noStrike" kern="1200" baseline="0" dirty="0">
+                      <a:solidFill>
+                        <a:srgbClr val="000000">
+                          <a:lumMod val="65000"/>
+                          <a:lumOff val="35000"/>
+                        </a:srgbClr>
+                      </a:solidFill>
+                    </a:endParaRPr>
+                  </a:p>
+                </c:rich>
+              </c:tx>
+              <c:spPr>
+                <a:solidFill>
+                  <a:prstClr val="white"/>
+                </a:solidFill>
+                <a:ln>
+                  <a:solidFill>
+                    <a:srgbClr val="000000">
+                      <a:lumMod val="25000"/>
+                      <a:lumOff val="75000"/>
+                    </a:srgbClr>
+                  </a:solidFill>
+                </a:ln>
+                <a:effectLst/>
+              </c:spPr>
+              <c:txPr>
+                <a:bodyPr rot="0" spcFirstLastPara="1" vertOverflow="clip" horzOverflow="clip" vert="horz" wrap="square" lIns="38100" tIns="19050" rIns="38100" bIns="19050" anchor="ctr" anchorCtr="0">
+                  <a:spAutoFit/>
+                </a:bodyPr>
+                <a:lstStyle/>
+                <a:p>
+                  <a:pPr marL="0" marR="0" lvl="0" indent="0" algn="ctr" defTabSz="914400" rtl="0" eaLnBrk="1" fontAlgn="auto" latinLnBrk="0" hangingPunct="1">
+                    <a:lnSpc>
+                      <a:spcPct val="100000"/>
+                    </a:lnSpc>
+                    <a:spcBef>
+                      <a:spcPts val="0"/>
+                    </a:spcBef>
+                    <a:spcAft>
+                      <a:spcPts val="0"/>
+                    </a:spcAft>
+                    <a:buClrTx/>
+                    <a:buSzTx/>
+                    <a:buFontTx/>
+                    <a:buNone/>
+                    <a:tabLst/>
+                    <a:defRPr sz="1197" b="0" i="0" u="none" strike="noStrike" kern="1200" baseline="0">
+                      <a:solidFill>
+                        <a:srgbClr val="000000">
+                          <a:lumMod val="65000"/>
+                          <a:lumOff val="35000"/>
+                        </a:srgbClr>
+                      </a:solidFill>
+                      <a:latin typeface="+mn-lt"/>
+                      <a:ea typeface="+mn-ea"/>
+                      <a:cs typeface="+mn-cs"/>
+                    </a:defRPr>
+                  </a:pPr>
+                  <a:endParaRPr lang="pl-PL"/>
+                </a:p>
+              </c:txPr>
+              <c:showLegendKey val="0"/>
+              <c:showVal val="1"/>
+              <c:showCatName val="1"/>
+              <c:showSerName val="0"/>
+              <c:showPercent val="0"/>
+              <c:showBubbleSize val="0"/>
+              <c:extLst>
+                <c:ext xmlns:c15="http://schemas.microsoft.com/office/drawing/2012/chart" uri="{CE6537A1-D6FC-4f65-9D91-7224C49458BB}">
+                  <c15:spPr xmlns:c15="http://schemas.microsoft.com/office/drawing/2012/chart">
+                    <a:prstGeom prst="wedgeRectCallout">
+                      <a:avLst/>
+                    </a:prstGeom>
+                    <a:noFill/>
+                    <a:ln>
+                      <a:noFill/>
+                    </a:ln>
+                  </c15:spPr>
+                  <c15:showDataLabelsRange val="0"/>
+                </c:ext>
+                <c:ext xmlns:c16="http://schemas.microsoft.com/office/drawing/2014/chart" uri="{C3380CC4-5D6E-409C-BE32-E72D297353CC}">
+                  <c16:uniqueId val="{00000003-0E4A-4E4E-B9CD-2ED98FD21E61}"/>
+                </c:ext>
+              </c:extLst>
+            </c:dLbl>
+            <c:dLbl>
+              <c:idx val="65"/>
+              <c:layout>
+                <c:manualLayout>
+                  <c:x val="-8.9245872378402494E-2"/>
+                  <c:y val="-0.13249909522708814"/>
+                </c:manualLayout>
+              </c:layout>
+              <c:tx>
+                <c:rich>
+                  <a:bodyPr rot="0" spcFirstLastPara="1" vertOverflow="clip" horzOverflow="clip" vert="horz" wrap="square" lIns="38100" tIns="19050" rIns="38100" bIns="19050" anchor="ctr" anchorCtr="0">
+                    <a:spAutoFit/>
+                  </a:bodyPr>
+                  <a:lstStyle/>
+                  <a:p>
+                    <a:pPr marL="0" marR="0" lvl="0" indent="0" algn="ctr" defTabSz="914400" rtl="0" eaLnBrk="1" fontAlgn="auto" latinLnBrk="0" hangingPunct="1">
+                      <a:lnSpc>
+                        <a:spcPct val="100000"/>
+                      </a:lnSpc>
+                      <a:spcBef>
+                        <a:spcPts val="0"/>
+                      </a:spcBef>
+                      <a:spcAft>
+                        <a:spcPts val="0"/>
+                      </a:spcAft>
+                      <a:buClrTx/>
+                      <a:buSzTx/>
+                      <a:buFontTx/>
+                      <a:buNone/>
+                      <a:tabLst/>
+                      <a:defRPr sz="1197" b="0" i="0" u="none" strike="noStrike" kern="1200" baseline="0">
+                        <a:solidFill>
+                          <a:srgbClr val="000000">
+                            <a:lumMod val="65000"/>
+                            <a:lumOff val="35000"/>
+                          </a:srgbClr>
+                        </a:solidFill>
+                        <a:latin typeface="+mn-lt"/>
+                        <a:ea typeface="+mn-ea"/>
+                        <a:cs typeface="+mn-cs"/>
+                      </a:defRPr>
+                    </a:pPr>
+                    <a:r>
+                      <a:rPr lang="en-US" sz="1197" b="0" i="0" u="none" strike="noStrike" kern="1200" baseline="0" dirty="0" err="1">
+                        <a:solidFill>
+                          <a:srgbClr val="000000">
+                            <a:lumMod val="65000"/>
+                            <a:lumOff val="35000"/>
+                          </a:srgbClr>
+                        </a:solidFill>
+                      </a:rPr>
+                      <a:t>Wygrana</a:t>
+                    </a:r>
+                    <a:r>
+                      <a:rPr lang="en-US" sz="1197" b="0" i="0" u="none" strike="noStrike" kern="1200" baseline="0" dirty="0">
+                        <a:solidFill>
+                          <a:srgbClr val="000000">
+                            <a:lumMod val="65000"/>
+                            <a:lumOff val="35000"/>
+                          </a:srgbClr>
+                        </a:solidFill>
+                      </a:rPr>
+                      <a:t> Rolanda </a:t>
+                    </a:r>
+                    <a:r>
+                      <a:rPr lang="en-US" sz="1197" b="0" i="0" u="none" strike="noStrike" kern="1200" baseline="0" dirty="0" err="1">
+                        <a:solidFill>
+                          <a:srgbClr val="000000">
+                            <a:lumMod val="65000"/>
+                            <a:lumOff val="35000"/>
+                          </a:srgbClr>
+                        </a:solidFill>
+                      </a:rPr>
+                      <a:t>Garrosa</a:t>
+                    </a:r>
+                    <a:endParaRPr lang="en-US" sz="1197" b="0" i="0" u="none" strike="noStrike" kern="1200" baseline="0" dirty="0">
+                      <a:solidFill>
+                        <a:srgbClr val="000000">
+                          <a:lumMod val="65000"/>
+                          <a:lumOff val="35000"/>
+                        </a:srgbClr>
+                      </a:solidFill>
+                    </a:endParaRPr>
+                  </a:p>
+                </c:rich>
+              </c:tx>
+              <c:spPr>
+                <a:solidFill>
+                  <a:prstClr val="white"/>
+                </a:solidFill>
+                <a:ln>
+                  <a:solidFill>
+                    <a:srgbClr val="000000">
+                      <a:lumMod val="25000"/>
+                      <a:lumOff val="75000"/>
+                    </a:srgbClr>
+                  </a:solidFill>
+                </a:ln>
+                <a:effectLst/>
+              </c:spPr>
+              <c:txPr>
+                <a:bodyPr rot="0" spcFirstLastPara="1" vertOverflow="clip" horzOverflow="clip" vert="horz" wrap="square" lIns="38100" tIns="19050" rIns="38100" bIns="19050" anchor="ctr" anchorCtr="0">
+                  <a:spAutoFit/>
+                </a:bodyPr>
+                <a:lstStyle/>
+                <a:p>
+                  <a:pPr marL="0" marR="0" lvl="0" indent="0" algn="ctr" defTabSz="914400" rtl="0" eaLnBrk="1" fontAlgn="auto" latinLnBrk="0" hangingPunct="1">
+                    <a:lnSpc>
+                      <a:spcPct val="100000"/>
+                    </a:lnSpc>
+                    <a:spcBef>
+                      <a:spcPts val="0"/>
+                    </a:spcBef>
+                    <a:spcAft>
+                      <a:spcPts val="0"/>
+                    </a:spcAft>
+                    <a:buClrTx/>
+                    <a:buSzTx/>
+                    <a:buFontTx/>
+                    <a:buNone/>
+                    <a:tabLst/>
+                    <a:defRPr sz="1197" b="0" i="0" u="none" strike="noStrike" kern="1200" baseline="0">
+                      <a:solidFill>
+                        <a:srgbClr val="000000">
+                          <a:lumMod val="65000"/>
+                          <a:lumOff val="35000"/>
+                        </a:srgbClr>
+                      </a:solidFill>
+                      <a:latin typeface="+mn-lt"/>
+                      <a:ea typeface="+mn-ea"/>
+                      <a:cs typeface="+mn-cs"/>
+                    </a:defRPr>
+                  </a:pPr>
+                  <a:endParaRPr lang="pl-PL"/>
+                </a:p>
+              </c:txPr>
+              <c:showLegendKey val="0"/>
+              <c:showVal val="1"/>
+              <c:showCatName val="1"/>
+              <c:showSerName val="0"/>
+              <c:showPercent val="0"/>
+              <c:showBubbleSize val="0"/>
+              <c:extLst>
+                <c:ext xmlns:c15="http://schemas.microsoft.com/office/drawing/2012/chart" uri="{CE6537A1-D6FC-4f65-9D91-7224C49458BB}">
+                  <c15:spPr xmlns:c15="http://schemas.microsoft.com/office/drawing/2012/chart">
+                    <a:prstGeom prst="wedgeRectCallout">
+                      <a:avLst/>
+                    </a:prstGeom>
+                    <a:noFill/>
+                    <a:ln>
+                      <a:noFill/>
+                    </a:ln>
+                  </c15:spPr>
+                  <c15:layout>
+                    <c:manualLayout>
+                      <c:w val="0.24901341147617592"/>
+                      <c:h val="9.5676866353506654E-2"/>
+                    </c:manualLayout>
+                  </c15:layout>
+                  <c15:showDataLabelsRange val="0"/>
+                </c:ext>
+                <c:ext xmlns:c16="http://schemas.microsoft.com/office/drawing/2014/chart" uri="{C3380CC4-5D6E-409C-BE32-E72D297353CC}">
+                  <c16:uniqueId val="{00000004-0E4A-4E4E-B9CD-2ED98FD21E61}"/>
+                </c:ext>
+              </c:extLst>
+            </c:dLbl>
+            <c:dLbl>
+              <c:idx val="77"/>
+              <c:layout>
+                <c:manualLayout>
+                  <c:x val="-0.17670682730923701"/>
+                  <c:y val="-0.16488776294926524"/>
+                </c:manualLayout>
+              </c:layout>
+              <c:tx>
+                <c:rich>
+                  <a:bodyPr rot="0" spcFirstLastPara="1" vertOverflow="clip" horzOverflow="clip" vert="horz" wrap="square" lIns="38100" tIns="19050" rIns="38100" bIns="19050" anchor="ctr" anchorCtr="0">
+                    <a:spAutoFit/>
+                  </a:bodyPr>
+                  <a:lstStyle/>
+                  <a:p>
+                    <a:pPr marL="0" marR="0" lvl="0" indent="0" algn="ctr" defTabSz="914400" rtl="0" eaLnBrk="1" fontAlgn="auto" latinLnBrk="0" hangingPunct="1">
+                      <a:lnSpc>
+                        <a:spcPct val="100000"/>
+                      </a:lnSpc>
+                      <a:spcBef>
+                        <a:spcPts val="0"/>
+                      </a:spcBef>
+                      <a:spcAft>
+                        <a:spcPts val="0"/>
+                      </a:spcAft>
+                      <a:buClrTx/>
+                      <a:buSzTx/>
+                      <a:buFontTx/>
+                      <a:buNone/>
+                      <a:tabLst/>
+                      <a:defRPr sz="1197" b="0" i="0" u="none" strike="noStrike" kern="1200" baseline="0">
+                        <a:solidFill>
+                          <a:srgbClr val="000000">
+                            <a:lumMod val="65000"/>
+                            <a:lumOff val="35000"/>
+                          </a:srgbClr>
+                        </a:solidFill>
+                        <a:latin typeface="+mn-lt"/>
+                        <a:ea typeface="+mn-ea"/>
+                        <a:cs typeface="+mn-cs"/>
+                      </a:defRPr>
+                    </a:pPr>
+                    <a:r>
+                      <a:rPr lang="en-US" dirty="0" err="1"/>
+                      <a:t>Kolejne</a:t>
+                    </a:r>
+                    <a:r>
+                      <a:rPr lang="en-US" baseline="0" dirty="0"/>
+                      <a:t> </a:t>
+                    </a:r>
+                    <a:r>
+                      <a:rPr lang="en-US" sz="1197" b="0" i="0" u="none" strike="noStrike" kern="1200" baseline="0" dirty="0" err="1">
+                        <a:solidFill>
+                          <a:srgbClr val="000000">
+                            <a:lumMod val="65000"/>
+                            <a:lumOff val="35000"/>
+                          </a:srgbClr>
+                        </a:solidFill>
+                      </a:rPr>
+                      <a:t>wygrane</a:t>
+                    </a:r>
+                    <a:r>
+                      <a:rPr lang="en-US" sz="1197" b="0" i="0" u="none" strike="noStrike" kern="1200" baseline="0" dirty="0">
+                        <a:solidFill>
+                          <a:srgbClr val="000000">
+                            <a:lumMod val="65000"/>
+                            <a:lumOff val="35000"/>
+                          </a:srgbClr>
+                        </a:solidFill>
+                      </a:rPr>
+                      <a:t> Rolanda </a:t>
+                    </a:r>
+                    <a:r>
+                      <a:rPr lang="en-US" sz="1197" b="0" i="0" u="none" strike="noStrike" kern="1200" baseline="0" dirty="0" err="1">
+                        <a:solidFill>
+                          <a:srgbClr val="000000">
+                            <a:lumMod val="65000"/>
+                            <a:lumOff val="35000"/>
+                          </a:srgbClr>
+                        </a:solidFill>
+                      </a:rPr>
+                      <a:t>Garrosa</a:t>
+                    </a:r>
+                    <a:endParaRPr lang="en-US" sz="1197" b="0" i="0" u="none" strike="noStrike" kern="1200" baseline="0" dirty="0">
+                      <a:solidFill>
+                        <a:srgbClr val="000000">
+                          <a:lumMod val="65000"/>
+                          <a:lumOff val="35000"/>
+                        </a:srgbClr>
+                      </a:solidFill>
+                    </a:endParaRPr>
+                  </a:p>
+                </c:rich>
+              </c:tx>
+              <c:spPr>
+                <a:solidFill>
+                  <a:prstClr val="white"/>
+                </a:solidFill>
+                <a:ln>
+                  <a:solidFill>
+                    <a:srgbClr val="000000">
+                      <a:lumMod val="25000"/>
+                      <a:lumOff val="75000"/>
+                    </a:srgbClr>
+                  </a:solidFill>
+                </a:ln>
+                <a:effectLst/>
+              </c:spPr>
+              <c:txPr>
+                <a:bodyPr rot="0" spcFirstLastPara="1" vertOverflow="clip" horzOverflow="clip" vert="horz" wrap="square" lIns="38100" tIns="19050" rIns="38100" bIns="19050" anchor="ctr" anchorCtr="0">
+                  <a:spAutoFit/>
+                </a:bodyPr>
+                <a:lstStyle/>
+                <a:p>
+                  <a:pPr marL="0" marR="0" lvl="0" indent="0" algn="ctr" defTabSz="914400" rtl="0" eaLnBrk="1" fontAlgn="auto" latinLnBrk="0" hangingPunct="1">
+                    <a:lnSpc>
+                      <a:spcPct val="100000"/>
+                    </a:lnSpc>
+                    <a:spcBef>
+                      <a:spcPts val="0"/>
+                    </a:spcBef>
+                    <a:spcAft>
+                      <a:spcPts val="0"/>
+                    </a:spcAft>
+                    <a:buClrTx/>
+                    <a:buSzTx/>
+                    <a:buFontTx/>
+                    <a:buNone/>
+                    <a:tabLst/>
+                    <a:defRPr sz="1197" b="0" i="0" u="none" strike="noStrike" kern="1200" baseline="0">
+                      <a:solidFill>
+                        <a:srgbClr val="000000">
+                          <a:lumMod val="65000"/>
+                          <a:lumOff val="35000"/>
+                        </a:srgbClr>
+                      </a:solidFill>
+                      <a:latin typeface="+mn-lt"/>
+                      <a:ea typeface="+mn-ea"/>
+                      <a:cs typeface="+mn-cs"/>
+                    </a:defRPr>
+                  </a:pPr>
+                  <a:endParaRPr lang="pl-PL"/>
+                </a:p>
+              </c:txPr>
+              <c:showLegendKey val="0"/>
+              <c:showVal val="1"/>
+              <c:showCatName val="1"/>
+              <c:showSerName val="0"/>
+              <c:showPercent val="0"/>
+              <c:showBubbleSize val="0"/>
+              <c:extLst>
+                <c:ext xmlns:c15="http://schemas.microsoft.com/office/drawing/2012/chart" uri="{CE6537A1-D6FC-4f65-9D91-7224C49458BB}">
+                  <c15:spPr xmlns:c15="http://schemas.microsoft.com/office/drawing/2012/chart">
+                    <a:prstGeom prst="wedgeRectCallout">
+                      <a:avLst/>
+                    </a:prstGeom>
+                    <a:noFill/>
+                    <a:ln>
+                      <a:noFill/>
+                    </a:ln>
+                  </c15:spPr>
+                  <c15:layout>
+                    <c:manualLayout>
+                      <c:w val="0.27848886359084635"/>
+                      <c:h val="9.5676866353506654E-2"/>
+                    </c:manualLayout>
+                  </c15:layout>
+                  <c15:showDataLabelsRange val="0"/>
+                </c:ext>
+                <c:ext xmlns:c16="http://schemas.microsoft.com/office/drawing/2014/chart" uri="{C3380CC4-5D6E-409C-BE32-E72D297353CC}">
+                  <c16:uniqueId val="{00000005-0E4A-4E4E-B9CD-2ED98FD21E61}"/>
+                </c:ext>
+              </c:extLst>
+            </c:dLbl>
+            <c:dLbl>
+              <c:idx val="90"/>
+              <c:layout>
+                <c:manualLayout>
+                  <c:x val="-7.1396697902721996E-3"/>
+                  <c:y val="-0.13838794390384768"/>
+                </c:manualLayout>
+              </c:layout>
+              <c:tx>
+                <c:rich>
+                  <a:bodyPr/>
+                  <a:lstStyle/>
+                  <a:p>
+                    <a:r>
+                      <a:rPr lang="en-US" dirty="0" err="1"/>
+                      <a:t>Wygrana</a:t>
+                    </a:r>
+                    <a:r>
+                      <a:rPr lang="en-US" dirty="0"/>
+                      <a:t> </a:t>
+                    </a:r>
+                    <a:r>
+                      <a:rPr lang="en-US" dirty="0" err="1"/>
+                      <a:t>Wimbledonu</a:t>
+                    </a:r>
+                    <a:endParaRPr lang="en-US" dirty="0"/>
+                  </a:p>
+                </c:rich>
+              </c:tx>
+              <c:showLegendKey val="0"/>
+              <c:showVal val="1"/>
+              <c:showCatName val="1"/>
+              <c:showSerName val="0"/>
+              <c:showPercent val="0"/>
+              <c:showBubbleSize val="0"/>
+              <c:extLst>
+                <c:ext xmlns:c15="http://schemas.microsoft.com/office/drawing/2012/chart" uri="{CE6537A1-D6FC-4f65-9D91-7224C49458BB}">
+                  <c15:showDataLabelsRange val="0"/>
+                </c:ext>
+                <c:ext xmlns:c16="http://schemas.microsoft.com/office/drawing/2014/chart" uri="{C3380CC4-5D6E-409C-BE32-E72D297353CC}">
+                  <c16:uniqueId val="{00000002-0E4A-4E4E-B9CD-2ED98FD21E61}"/>
+                </c:ext>
+              </c:extLst>
+            </c:dLbl>
+            <c:spPr>
+              <a:solidFill>
+                <a:prstClr val="white"/>
+              </a:solidFill>
+              <a:ln>
+                <a:solidFill>
+                  <a:srgbClr val="000000">
+                    <a:lumMod val="25000"/>
+                    <a:lumOff val="75000"/>
+                  </a:srgbClr>
+                </a:solidFill>
+              </a:ln>
+              <a:effectLst/>
+            </c:spPr>
+            <c:txPr>
+              <a:bodyPr rot="0" spcFirstLastPara="1" vertOverflow="clip" horzOverflow="clip" vert="horz" wrap="square" lIns="38100" tIns="19050" rIns="38100" bIns="19050" anchor="ctr" anchorCtr="1">
+                <a:spAutoFit/>
+              </a:bodyPr>
+              <a:lstStyle/>
+              <a:p>
+                <a:pPr>
+                  <a:defRPr sz="1197" b="0" i="0" u="none" strike="noStrike" kern="1200" baseline="0">
+                    <a:solidFill>
+                      <a:schemeClr val="dk1">
+                        <a:lumMod val="65000"/>
+                        <a:lumOff val="35000"/>
+                      </a:schemeClr>
+                    </a:solidFill>
+                    <a:latin typeface="+mn-lt"/>
+                    <a:ea typeface="+mn-ea"/>
+                    <a:cs typeface="+mn-cs"/>
+                  </a:defRPr>
+                </a:pPr>
+                <a:endParaRPr lang="pl-PL"/>
+              </a:p>
+            </c:txPr>
+            <c:showLegendKey val="0"/>
+            <c:showVal val="0"/>
+            <c:showCatName val="0"/>
+            <c:showSerName val="0"/>
+            <c:showPercent val="0"/>
+            <c:showBubbleSize val="0"/>
+            <c:extLst>
+              <c:ext xmlns:c15="http://schemas.microsoft.com/office/drawing/2012/chart" uri="{CE6537A1-D6FC-4f65-9D91-7224C49458BB}">
+                <c15:spPr xmlns:c15="http://schemas.microsoft.com/office/drawing/2012/chart">
+                  <a:prstGeom prst="wedgeRectCallout">
+                    <a:avLst/>
+                  </a:prstGeom>
+                  <a:noFill/>
+                  <a:ln>
+                    <a:noFill/>
+                  </a:ln>
+                </c15:spPr>
+                <c15:showLeaderLines val="0"/>
+              </c:ext>
+            </c:extLst>
+          </c:dLbls>
           <c:cat>
             <c:numRef>
               <c:f>Arkusz1!$A$2:$A$105</c:f>
@@ -4312,7 +5049,7 @@
                   <a:schemeClr val="tx1"/>
                 </a:solidFill>
               </a:rPr>
-              <a:t>[tys.][4]</a:t>
+              <a:t>[tys.]</a:t>
             </a:r>
             <a:endParaRPr lang="en-US" sz="1800" dirty="0">
               <a:solidFill>
@@ -5384,7 +6121,7 @@
                   <a:schemeClr val="tx1"/>
                 </a:solidFill>
               </a:rPr>
-              <a:t>Republika Zielonego Przylądka oraz Curaçao [tys.][4]</a:t>
+              <a:t>Republika Zielonego Przylądka oraz Curaçao [tys.]</a:t>
             </a:r>
             <a:endParaRPr lang="en-US" sz="1800" dirty="0">
               <a:solidFill>
@@ -6994,7 +7731,7 @@
                   <a:schemeClr val="tx1"/>
                 </a:solidFill>
               </a:rPr>
-              <a:t>[mln][4]</a:t>
+              <a:t>[mln]</a:t>
             </a:r>
             <a:endParaRPr lang="en-US" sz="1800" dirty="0">
               <a:solidFill>
@@ -12355,7 +13092,7 @@
           <a:p>
             <a:fld id="{3A47170D-57BC-4138-8517-84641EEC49C6}" type="datetimeFigureOut">
               <a:rPr lang="pl-PL" smtClean="0"/>
-              <a:t>17.10.2026</a:t>
+              <a:t>01.11.2026</a:t>
             </a:fld>
             <a:endParaRPr lang="pl-PL"/>
           </a:p>
@@ -12548,7 +13285,7 @@
           <a:p>
             <a:fld id="{E5935C60-06B4-43D2-8FB6-7E8AA44FCC6B}" type="datetimeFigureOut">
               <a:rPr lang="pl-PL" smtClean="0"/>
-              <a:t>17.10.2026</a:t>
+              <a:t>01.11.2026</a:t>
             </a:fld>
             <a:endParaRPr lang="pl-PL"/>
           </a:p>
@@ -12922,6 +13659,90 @@
 </p:notes>
 </file>
 
+<file path=ppt/notesSlides/notesSlide2.xml><?xml version="1.0" encoding="utf-8"?>
+<p:notes xmlns:a="http://schemas.openxmlformats.org/drawingml/2006/main" xmlns:r="http://schemas.openxmlformats.org/officeDocument/2006/relationships" xmlns:p="http://schemas.openxmlformats.org/presentationml/2006/main">
+  <p:cSld>
+    <p:spTree>
+      <p:nvGrpSpPr>
+        <p:cNvPr id="1" name=""/>
+        <p:cNvGrpSpPr/>
+        <p:nvPr/>
+      </p:nvGrpSpPr>
+      <p:grpSpPr>
+        <a:xfrm>
+          <a:off x="0" y="0"/>
+          <a:ext cx="0" cy="0"/>
+          <a:chOff x="0" y="0"/>
+          <a:chExt cx="0" cy="0"/>
+        </a:xfrm>
+      </p:grpSpPr>
+      <p:sp>
+        <p:nvSpPr>
+          <p:cNvPr id="2" name="Symbol zastępczy obrazu slajdu 1"/>
+          <p:cNvSpPr>
+            <a:spLocks noGrp="1" noRot="1" noChangeAspect="1"/>
+          </p:cNvSpPr>
+          <p:nvPr>
+            <p:ph type="sldImg"/>
+          </p:nvPr>
+        </p:nvSpPr>
+        <p:spPr/>
+      </p:sp>
+      <p:sp>
+        <p:nvSpPr>
+          <p:cNvPr id="3" name="Symbol zastępczy notatek 2"/>
+          <p:cNvSpPr>
+            <a:spLocks noGrp="1"/>
+          </p:cNvSpPr>
+          <p:nvPr>
+            <p:ph type="body" idx="1"/>
+          </p:nvPr>
+        </p:nvSpPr>
+        <p:spPr/>
+        <p:txBody>
+          <a:bodyPr/>
+          <a:lstStyle/>
+          <a:p>
+            <a:endParaRPr lang="pl-PL" dirty="0"/>
+          </a:p>
+        </p:txBody>
+      </p:sp>
+      <p:sp>
+        <p:nvSpPr>
+          <p:cNvPr id="4" name="Symbol zastępczy numeru slajdu 3"/>
+          <p:cNvSpPr>
+            <a:spLocks noGrp="1"/>
+          </p:cNvSpPr>
+          <p:nvPr>
+            <p:ph type="sldNum" sz="quarter" idx="5"/>
+          </p:nvPr>
+        </p:nvSpPr>
+        <p:spPr/>
+        <p:txBody>
+          <a:bodyPr/>
+          <a:lstStyle/>
+          <a:p>
+            <a:fld id="{1795FADB-00C8-4FB2-BB50-76DE30578D93}" type="slidenum">
+              <a:rPr lang="pl-PL" smtClean="0"/>
+              <a:t>6</a:t>
+            </a:fld>
+            <a:endParaRPr lang="pl-PL"/>
+          </a:p>
+        </p:txBody>
+      </p:sp>
+    </p:spTree>
+    <p:extLst>
+      <p:ext uri="{BB962C8B-B14F-4D97-AF65-F5344CB8AC3E}">
+        <p14:creationId xmlns:p14="http://schemas.microsoft.com/office/powerpoint/2010/main" val="1143670020"/>
+      </p:ext>
+    </p:extLst>
+  </p:cSld>
+  <p:clrMapOvr>
+    <a:masterClrMapping/>
+  </p:clrMapOvr>
+</p:notes>
+</file>
+
 <file path=ppt/slideLayouts/slideLayout1.xml><?xml version="1.0" encoding="utf-8"?>
 <p:sldLayout xmlns:a="http://schemas.openxmlformats.org/drawingml/2006/main" xmlns:r="http://schemas.openxmlformats.org/officeDocument/2006/relationships" xmlns:p="http://schemas.openxmlformats.org/presentationml/2006/main" type="title" preserve="1">
   <p:cSld name="Slajd tytułowy">
@@ -13069,7 +13890,7 @@
           <a:p>
             <a:fld id="{395FEE27-536F-479E-B304-98213E6B58CC}" type="datetimeFigureOut">
               <a:rPr lang="pl-PL" smtClean="0"/>
-              <a:t>17.10.2026</a:t>
+              <a:t>01.11.2026</a:t>
             </a:fld>
             <a:endParaRPr lang="pl-PL"/>
           </a:p>
@@ -13357,7 +14178,7 @@
           <a:p>
             <a:fld id="{395FEE27-536F-479E-B304-98213E6B58CC}" type="datetimeFigureOut">
               <a:rPr lang="pl-PL" smtClean="0"/>
-              <a:t>17.10.2026</a:t>
+              <a:t>01.11.2026</a:t>
             </a:fld>
             <a:endParaRPr lang="pl-PL"/>
           </a:p>
@@ -13555,7 +14376,7 @@
           <a:p>
             <a:fld id="{395FEE27-536F-479E-B304-98213E6B58CC}" type="datetimeFigureOut">
               <a:rPr lang="pl-PL" smtClean="0"/>
-              <a:t>17.10.2026</a:t>
+              <a:t>01.11.2026</a:t>
             </a:fld>
             <a:endParaRPr lang="pl-PL"/>
           </a:p>
@@ -13763,7 +14584,7 @@
           <a:p>
             <a:fld id="{395FEE27-536F-479E-B304-98213E6B58CC}" type="datetimeFigureOut">
               <a:rPr lang="pl-PL" smtClean="0"/>
-              <a:t>17.10.2026</a:t>
+              <a:t>01.11.2026</a:t>
             </a:fld>
             <a:endParaRPr lang="pl-PL"/>
           </a:p>
@@ -13961,7 +14782,7 @@
           <a:p>
             <a:fld id="{395FEE27-536F-479E-B304-98213E6B58CC}" type="datetimeFigureOut">
               <a:rPr lang="pl-PL" smtClean="0"/>
-              <a:t>17.10.2026</a:t>
+              <a:t>01.11.2026</a:t>
             </a:fld>
             <a:endParaRPr lang="pl-PL"/>
           </a:p>
@@ -14167,7 +14988,7 @@
         <p:spPr>
           <a:xfrm>
             <a:off x="8070852" y="1449704"/>
-            <a:ext cx="3416299" cy="4312920"/>
+            <a:ext cx="3416299" cy="4174809"/>
           </a:xfrm>
           <a:prstGeom prst="roundRect">
             <a:avLst>
@@ -14231,7 +15052,7 @@
           <a:p>
             <a:fld id="{395FEE27-536F-479E-B304-98213E6B58CC}" type="datetimeFigureOut">
               <a:rPr lang="pl-PL" smtClean="0"/>
-              <a:t>17.10.2026</a:t>
+              <a:t>01.11.2026</a:t>
             </a:fld>
             <a:endParaRPr lang="pl-PL"/>
           </a:p>
@@ -14310,7 +15131,7 @@
         <p:spPr>
           <a:xfrm>
             <a:off x="8070851" y="1449704"/>
-            <a:ext cx="3416299" cy="4312920"/>
+            <a:ext cx="3416299" cy="4174809"/>
           </a:xfrm>
           <a:noFill/>
           <a:ln>
@@ -14369,7 +15190,12 @@
   <p:extLst>
     <p:ext uri="{DCECCB84-F9BA-43D5-87BE-67443E8EF086}">
       <p15:sldGuideLst xmlns:p15="http://schemas.microsoft.com/office/powerpoint/2012/main">
-        <p15:guide id="1" orient="horz" pos="2160" userDrawn="1">
+        <p15:guide id="1" orient="horz" pos="3543" userDrawn="1">
+          <p15:clr>
+            <a:srgbClr val="FBAE40"/>
+          </p15:clr>
+        </p15:guide>
+        <p15:guide id="2" orient="horz" pos="2260" userDrawn="1">
           <p15:clr>
             <a:srgbClr val="FBAE40"/>
           </p15:clr>
@@ -14582,7 +15408,7 @@
           <a:p>
             <a:fld id="{395FEE27-536F-479E-B304-98213E6B58CC}" type="datetimeFigureOut">
               <a:rPr lang="pl-PL" smtClean="0"/>
-              <a:t>17.10.2026</a:t>
+              <a:t>01.11.2026</a:t>
             </a:fld>
             <a:endParaRPr lang="pl-PL"/>
           </a:p>
@@ -14847,7 +15673,7 @@
           <a:p>
             <a:fld id="{395FEE27-536F-479E-B304-98213E6B58CC}" type="datetimeFigureOut">
               <a:rPr lang="pl-PL" smtClean="0"/>
-              <a:t>17.10.2026</a:t>
+              <a:t>01.11.2026</a:t>
             </a:fld>
             <a:endParaRPr lang="pl-PL"/>
           </a:p>
@@ -15259,7 +16085,7 @@
           <a:p>
             <a:fld id="{395FEE27-536F-479E-B304-98213E6B58CC}" type="datetimeFigureOut">
               <a:rPr lang="pl-PL" smtClean="0"/>
-              <a:t>17.10.2026</a:t>
+              <a:t>01.11.2026</a:t>
             </a:fld>
             <a:endParaRPr lang="pl-PL"/>
           </a:p>
@@ -15400,7 +16226,7 @@
           <a:p>
             <a:fld id="{395FEE27-536F-479E-B304-98213E6B58CC}" type="datetimeFigureOut">
               <a:rPr lang="pl-PL" smtClean="0"/>
-              <a:t>17.10.2026</a:t>
+              <a:t>01.11.2026</a:t>
             </a:fld>
             <a:endParaRPr lang="pl-PL"/>
           </a:p>
@@ -15513,7 +16339,7 @@
           <a:p>
             <a:fld id="{395FEE27-536F-479E-B304-98213E6B58CC}" type="datetimeFigureOut">
               <a:rPr lang="pl-PL" smtClean="0"/>
-              <a:t>17.10.2026</a:t>
+              <a:t>01.11.2026</a:t>
             </a:fld>
             <a:endParaRPr lang="pl-PL"/>
           </a:p>
@@ -15824,7 +16650,7 @@
           <a:p>
             <a:fld id="{395FEE27-536F-479E-B304-98213E6B58CC}" type="datetimeFigureOut">
               <a:rPr lang="pl-PL" smtClean="0"/>
-              <a:t>17.10.2026</a:t>
+              <a:t>01.11.2026</a:t>
             </a:fld>
             <a:endParaRPr lang="pl-PL"/>
           </a:p>
@@ -16068,7 +16894,7 @@
           <a:p>
             <a:fld id="{395FEE27-536F-479E-B304-98213E6B58CC}" type="datetimeFigureOut">
               <a:rPr lang="pl-PL" smtClean="0"/>
-              <a:t>17.10.2026</a:t>
+              <a:t>01.11.2026</a:t>
             </a:fld>
             <a:endParaRPr lang="pl-PL"/>
           </a:p>
@@ -16726,8 +17552,8 @@
         </p:nvSpPr>
         <p:spPr>
           <a:xfrm>
-            <a:off x="837526" y="4834913"/>
-            <a:ext cx="10515600" cy="937237"/>
+            <a:off x="695325" y="4834913"/>
+            <a:ext cx="10801349" cy="937237"/>
           </a:xfrm>
           <a:prstGeom prst="rect">
             <a:avLst/>
@@ -16911,7 +17737,14 @@
             </a:pPr>
             <a:r>
               <a:rPr lang="pl-PL" sz="2400" dirty="0"/>
-              <a:t>Przez ostatnie 25 lat zadaliśmy miliardy pytań w polskiej Wikipedii. Sprawdźmy, czego dotyczą, kiedy się pojawiają i dlaczego.</a:t>
+              <a:t>Przez 25 lat Wikipedia nie była tylko encyklopedią. </a:t>
+            </a:r>
+            <a:br>
+              <a:rPr lang="pl-PL" sz="2400" dirty="0"/>
+            </a:br>
+            <a:r>
+              <a:rPr lang="pl-PL" sz="2400" dirty="0"/>
+              <a:t>Była miejscem, do którego trafialiśmy, gdy działo się coś ważnego.</a:t>
             </a:r>
           </a:p>
         </p:txBody>
@@ -16930,6 +17763,135 @@
 </file>
 
 <file path=ppt/slides/slide10.xml><?xml version="1.0" encoding="utf-8"?>
+<p:sld xmlns:a="http://schemas.openxmlformats.org/drawingml/2006/main" xmlns:r="http://schemas.openxmlformats.org/officeDocument/2006/relationships" xmlns:p="http://schemas.openxmlformats.org/presentationml/2006/main" show="0">
+  <p:cSld>
+    <p:spTree>
+      <p:nvGrpSpPr>
+        <p:cNvPr id="1" name="">
+          <a:extLst>
+            <a:ext uri="{FF2B5EF4-FFF2-40B4-BE49-F238E27FC236}">
+              <a16:creationId xmlns:a16="http://schemas.microsoft.com/office/drawing/2014/main" id="{21897F48-AF87-1935-680A-A761D3CA20C5}"/>
+            </a:ext>
+          </a:extLst>
+        </p:cNvPr>
+        <p:cNvGrpSpPr/>
+        <p:nvPr/>
+      </p:nvGrpSpPr>
+      <p:grpSpPr>
+        <a:xfrm>
+          <a:off x="0" y="0"/>
+          <a:ext cx="0" cy="0"/>
+          <a:chOff x="0" y="0"/>
+          <a:chExt cx="0" cy="0"/>
+        </a:xfrm>
+      </p:grpSpPr>
+      <p:sp>
+        <p:nvSpPr>
+          <p:cNvPr id="2" name="Tytuł 1">
+            <a:extLst>
+              <a:ext uri="{FF2B5EF4-FFF2-40B4-BE49-F238E27FC236}">
+                <a16:creationId xmlns:a16="http://schemas.microsoft.com/office/drawing/2014/main" id="{DE7A4FF8-5762-F565-D0C2-521912B3ACD8}"/>
+              </a:ext>
+            </a:extLst>
+          </p:cNvPr>
+          <p:cNvSpPr>
+            <a:spLocks noGrp="1"/>
+          </p:cNvSpPr>
+          <p:nvPr>
+            <p:ph type="title"/>
+          </p:nvPr>
+        </p:nvSpPr>
+        <p:spPr/>
+        <p:txBody>
+          <a:bodyPr>
+            <a:noAutofit/>
+          </a:bodyPr>
+          <a:lstStyle/>
+          <a:p>
+            <a:r>
+              <a:rPr lang="pl-PL" dirty="0"/>
+              <a:t>Dlaczego otwieramy Wikipedię?</a:t>
+            </a:r>
+          </a:p>
+        </p:txBody>
+      </p:sp>
+      <p:sp>
+        <p:nvSpPr>
+          <p:cNvPr id="3" name="Symbol zastępczy zawartości 2">
+            <a:extLst>
+              <a:ext uri="{FF2B5EF4-FFF2-40B4-BE49-F238E27FC236}">
+                <a16:creationId xmlns:a16="http://schemas.microsoft.com/office/drawing/2014/main" id="{D38FDE60-81F8-8812-1058-CE3E9E55C7D3}"/>
+              </a:ext>
+            </a:extLst>
+          </p:cNvPr>
+          <p:cNvSpPr>
+            <a:spLocks noGrp="1"/>
+          </p:cNvSpPr>
+          <p:nvPr>
+            <p:ph idx="1"/>
+          </p:nvPr>
+        </p:nvSpPr>
+        <p:spPr/>
+        <p:txBody>
+          <a:bodyPr/>
+          <a:lstStyle/>
+          <a:p>
+            <a:pPr marL="0" indent="0">
+              <a:buNone/>
+            </a:pPr>
+            <a:r>
+              <a:rPr lang="pl-PL" dirty="0">
+                <a:solidFill>
+                  <a:schemeClr val="tx2"/>
+                </a:solidFill>
+              </a:rPr>
+              <a:t>Analiza powyższych przykładów pokazuje, że Wikipedia nie jest tylko encyklopedią. </a:t>
+            </a:r>
+          </a:p>
+          <a:p>
+            <a:pPr marL="0" indent="0">
+              <a:buNone/>
+            </a:pPr>
+            <a:r>
+              <a:rPr lang="pl-PL" dirty="0">
+                <a:solidFill>
+                  <a:schemeClr val="tx2"/>
+                </a:solidFill>
+              </a:rPr>
+              <a:t>Jest miejscem do którego udajemy się, by zrozumieć świat wokół nas. By zgłębić wydarzenia wywołujące smutek, strach, ciekawość czy ekscytację.</a:t>
+            </a:r>
+          </a:p>
+          <a:p>
+            <a:pPr marL="0" indent="0">
+              <a:buNone/>
+            </a:pPr>
+            <a:endParaRPr lang="pl-PL" dirty="0"/>
+          </a:p>
+          <a:p>
+            <a:pPr marL="0" indent="0">
+              <a:buNone/>
+            </a:pPr>
+            <a:r>
+              <a:rPr lang="pl-PL" b="1" dirty="0"/>
+              <a:t>Wikipedia odpowiada na nasze emocje. Od 25 lat.</a:t>
+            </a:r>
+          </a:p>
+        </p:txBody>
+      </p:sp>
+    </p:spTree>
+    <p:extLst>
+      <p:ext uri="{BB962C8B-B14F-4D97-AF65-F5344CB8AC3E}">
+        <p14:creationId xmlns:p14="http://schemas.microsoft.com/office/powerpoint/2010/main" val="769765417"/>
+      </p:ext>
+    </p:extLst>
+  </p:cSld>
+  <p:clrMapOvr>
+    <a:masterClrMapping/>
+  </p:clrMapOvr>
+</p:sld>
+</file>
+
+<file path=ppt/slides/slide11.xml><?xml version="1.0" encoding="utf-8"?>
 <p:sld xmlns:a="http://schemas.openxmlformats.org/drawingml/2006/main" xmlns:r="http://schemas.openxmlformats.org/officeDocument/2006/relationships" xmlns:p="http://schemas.openxmlformats.org/presentationml/2006/main">
   <p:cSld>
     <p:spTree>
@@ -16995,7 +17957,7 @@
 </p:sld>
 </file>
 
-<file path=ppt/slides/slide11.xml><?xml version="1.0" encoding="utf-8"?>
+<file path=ppt/slides/slide12.xml><?xml version="1.0" encoding="utf-8"?>
 <p:sld xmlns:a="http://schemas.openxmlformats.org/drawingml/2006/main" xmlns:r="http://schemas.openxmlformats.org/officeDocument/2006/relationships" xmlns:p="http://schemas.openxmlformats.org/presentationml/2006/main">
   <p:cSld>
     <p:spTree>
@@ -17458,7 +18420,7 @@
 </p:sld>
 </file>
 
-<file path=ppt/slides/slide12.xml><?xml version="1.0" encoding="utf-8"?>
+<file path=ppt/slides/slide13.xml><?xml version="1.0" encoding="utf-8"?>
 <p:sld xmlns:a="http://schemas.openxmlformats.org/drawingml/2006/main" xmlns:r="http://schemas.openxmlformats.org/officeDocument/2006/relationships" xmlns:p="http://schemas.openxmlformats.org/presentationml/2006/main">
   <p:cSld>
     <p:spTree>
@@ -17527,7 +18489,7 @@
             <p:ph idx="1"/>
             <p:extLst>
               <p:ext uri="{D42A27DB-BD31-4B8C-83A1-F6EECF244321}">
-                <p14:modId xmlns:p14="http://schemas.microsoft.com/office/powerpoint/2010/main" val="2952152747"/>
+                <p14:modId xmlns:p14="http://schemas.microsoft.com/office/powerpoint/2010/main" val="1656004559"/>
               </p:ext>
             </p:extLst>
           </p:nvPr>
@@ -17570,12 +18532,20 @@
               <a:t>Mediana miesięcznych wyświetleń strony Przedłużanie życia wynosi </a:t>
             </a:r>
             <a:r>
-              <a:rPr lang="pl-PL" b="1" u="sng" dirty="0"/>
+              <a:rPr lang="pl-PL" b="1" u="sng" dirty="0">
+                <a:latin typeface="Montserrat" pitchFamily="2" charset="-18"/>
+              </a:rPr>
               <a:t>455</a:t>
             </a:r>
             <a:r>
+              <a:rPr lang="pl-PL" dirty="0">
+                <a:latin typeface="Montserrat" pitchFamily="2" charset="-18"/>
+              </a:rPr>
+              <a:t>.</a:t>
+            </a:r>
+            <a:r>
               <a:rPr lang="pl-PL" dirty="0"/>
-              <a:t>. </a:t>
+              <a:t> </a:t>
             </a:r>
           </a:p>
           <a:p>
@@ -17867,7 +18837,7 @@
 </file>
 
 <file path=ppt/slides/slide2.xml><?xml version="1.0" encoding="utf-8"?>
-<p:sld xmlns:a="http://schemas.openxmlformats.org/drawingml/2006/main" xmlns:r="http://schemas.openxmlformats.org/officeDocument/2006/relationships" xmlns:p="http://schemas.openxmlformats.org/presentationml/2006/main">
+<p:sld xmlns:a="http://schemas.openxmlformats.org/drawingml/2006/main" xmlns:r="http://schemas.openxmlformats.org/officeDocument/2006/relationships" xmlns:p="http://schemas.openxmlformats.org/presentationml/2006/main" show="0">
   <p:cSld>
     <p:spTree>
       <p:nvGrpSpPr>
@@ -17898,7 +18868,7 @@
         <p:spPr>
           <a:xfrm>
             <a:off x="8080374" y="1455421"/>
-            <a:ext cx="3416299" cy="4312920"/>
+            <a:ext cx="3416299" cy="4169092"/>
           </a:xfrm>
           <a:prstGeom prst="roundRect">
             <a:avLst>
@@ -18389,7 +19359,7 @@
                   <a:schemeClr val="tx2"/>
                 </a:solidFill>
               </a:rPr>
-              <a:t>w przestrzeni publicznej. [5]</a:t>
+              <a:t>w przestrzeni publicznej. [4][5]</a:t>
             </a:r>
           </a:p>
         </p:txBody>
@@ -18445,7 +19415,7 @@
             <p:ph idx="1"/>
             <p:extLst>
               <p:ext uri="{D42A27DB-BD31-4B8C-83A1-F6EECF244321}">
-                <p14:modId xmlns:p14="http://schemas.microsoft.com/office/powerpoint/2010/main" val="3210160099"/>
+                <p14:modId xmlns:p14="http://schemas.microsoft.com/office/powerpoint/2010/main" val="3002254639"/>
               </p:ext>
             </p:extLst>
           </p:nvPr>
@@ -18632,7 +19602,7 @@
             <p:ph idx="1"/>
             <p:extLst>
               <p:ext uri="{D42A27DB-BD31-4B8C-83A1-F6EECF244321}">
-                <p14:modId xmlns:p14="http://schemas.microsoft.com/office/powerpoint/2010/main" val="612455224"/>
+                <p14:modId xmlns:p14="http://schemas.microsoft.com/office/powerpoint/2010/main" val="1362658393"/>
               </p:ext>
             </p:extLst>
           </p:nvPr>
@@ -18691,6 +19661,7 @@
                 <a:solidFill>
                   <a:schemeClr val="accent5"/>
                 </a:solidFill>
+                <a:latin typeface="Montserrat" pitchFamily="2" charset="-18"/>
               </a:rPr>
               <a:t>wydarzenia wywołujące różne emocje. </a:t>
             </a:r>
@@ -18717,6 +19688,7 @@
                 <a:solidFill>
                   <a:schemeClr val="accent2"/>
                 </a:solidFill>
+                <a:latin typeface="Montserrat" pitchFamily="2" charset="-18"/>
               </a:rPr>
               <a:t>doniesienia medialne oraz nowe produkcje popkultury.</a:t>
             </a:r>
@@ -18727,6 +19699,7 @@
                 <a:solidFill>
                   <a:schemeClr val="tx2"/>
                 </a:solidFill>
+                <a:latin typeface="Montserrat" pitchFamily="2" charset="-18"/>
               </a:rPr>
               <a:t>Za każdą kategorią kryją się konkretne historie.</a:t>
             </a:r>
@@ -18767,7 +19740,7 @@
                   <a:schemeClr val="tx2"/>
                 </a:solidFill>
               </a:rPr>
-              <a:t>Kategorie dopasowane przez model językowy</a:t>
+              <a:t>Kategorie dopasowane przez model językowy [6]</a:t>
             </a:r>
           </a:p>
         </p:txBody>
@@ -18852,7 +19825,7 @@
             <p:ph idx="1"/>
             <p:extLst>
               <p:ext uri="{D42A27DB-BD31-4B8C-83A1-F6EECF244321}">
-                <p14:modId xmlns:p14="http://schemas.microsoft.com/office/powerpoint/2010/main" val="1424739551"/>
+                <p14:modId xmlns:p14="http://schemas.microsoft.com/office/powerpoint/2010/main" val="1554790411"/>
               </p:ext>
             </p:extLst>
           </p:nvPr>
@@ -18932,6 +19905,51 @@
                 </a:solidFill>
               </a:rPr>
               <a:t>.</a:t>
+            </a:r>
+          </a:p>
+        </p:txBody>
+      </p:sp>
+      <p:sp>
+        <p:nvSpPr>
+          <p:cNvPr id="5" name="pole tekstowe 4">
+            <a:extLst>
+              <a:ext uri="{FF2B5EF4-FFF2-40B4-BE49-F238E27FC236}">
+                <a16:creationId xmlns:a16="http://schemas.microsoft.com/office/drawing/2014/main" id="{5053E86D-93C9-BD0A-6FF4-6E65101A571A}"/>
+              </a:ext>
+            </a:extLst>
+          </p:cNvPr>
+          <p:cNvSpPr txBox="1"/>
+          <p:nvPr/>
+        </p:nvSpPr>
+        <p:spPr>
+          <a:xfrm>
+            <a:off x="695325" y="6251109"/>
+            <a:ext cx="9568976" cy="276999"/>
+          </a:xfrm>
+          <a:prstGeom prst="rect">
+            <a:avLst/>
+          </a:prstGeom>
+          <a:noFill/>
+        </p:spPr>
+        <p:txBody>
+          <a:bodyPr wrap="square" rtlCol="0">
+            <a:spAutoFit/>
+          </a:bodyPr>
+          <a:lstStyle/>
+          <a:p>
+            <a:r>
+              <a:rPr lang="pl-PL" sz="1200" dirty="0">
+                <a:solidFill>
+                  <a:schemeClr val="tx2"/>
+                </a:solidFill>
+              </a:rPr>
+              <a:t>Na podstawie </a:t>
+            </a:r>
+            <a:r>
+              <a:rPr lang="pl-PL" sz="1200" dirty="0">
+                <a:latin typeface="Aptos" panose="020B0004020202020204" pitchFamily="34" charset="0"/>
+              </a:rPr>
+              <a:t>https://pageviews.wmcloud.org/ [4][8]  </a:t>
             </a:r>
           </a:p>
         </p:txBody>
@@ -19018,7 +20036,7 @@
             <p:ph idx="1"/>
             <p:extLst>
               <p:ext uri="{D42A27DB-BD31-4B8C-83A1-F6EECF244321}">
-                <p14:modId xmlns:p14="http://schemas.microsoft.com/office/powerpoint/2010/main" val="2348663486"/>
+                <p14:modId xmlns:p14="http://schemas.microsoft.com/office/powerpoint/2010/main" val="2569581845"/>
               </p:ext>
             </p:extLst>
           </p:nvPr>
@@ -19029,7 +20047,7 @@
         </p:xfrm>
         <a:graphic>
           <a:graphicData uri="http://schemas.openxmlformats.org/drawingml/2006/chart">
-            <c:chart xmlns:c="http://schemas.openxmlformats.org/drawingml/2006/chart" xmlns:r="http://schemas.openxmlformats.org/officeDocument/2006/relationships" r:id="rId2"/>
+            <c:chart xmlns:c="http://schemas.openxmlformats.org/drawingml/2006/chart" xmlns:r="http://schemas.openxmlformats.org/officeDocument/2006/relationships" r:id="rId3"/>
           </a:graphicData>
         </a:graphic>
       </p:graphicFrame>
@@ -19120,6 +20138,51 @@
           </a:p>
           <a:p>
             <a:endParaRPr lang="pl-PL" dirty="0"/>
+          </a:p>
+        </p:txBody>
+      </p:sp>
+      <p:sp>
+        <p:nvSpPr>
+          <p:cNvPr id="5" name="pole tekstowe 4">
+            <a:extLst>
+              <a:ext uri="{FF2B5EF4-FFF2-40B4-BE49-F238E27FC236}">
+                <a16:creationId xmlns:a16="http://schemas.microsoft.com/office/drawing/2014/main" id="{900168F3-3B2A-A2A5-4D31-54DD250344D0}"/>
+              </a:ext>
+            </a:extLst>
+          </p:cNvPr>
+          <p:cNvSpPr txBox="1"/>
+          <p:nvPr/>
+        </p:nvSpPr>
+        <p:spPr>
+          <a:xfrm>
+            <a:off x="695325" y="6251109"/>
+            <a:ext cx="9568976" cy="276999"/>
+          </a:xfrm>
+          <a:prstGeom prst="rect">
+            <a:avLst/>
+          </a:prstGeom>
+          <a:noFill/>
+        </p:spPr>
+        <p:txBody>
+          <a:bodyPr wrap="square" rtlCol="0">
+            <a:spAutoFit/>
+          </a:bodyPr>
+          <a:lstStyle/>
+          <a:p>
+            <a:r>
+              <a:rPr lang="pl-PL" sz="1200" dirty="0">
+                <a:solidFill>
+                  <a:schemeClr val="tx2"/>
+                </a:solidFill>
+              </a:rPr>
+              <a:t>Na podstawie </a:t>
+            </a:r>
+            <a:r>
+              <a:rPr lang="pl-PL" sz="1200" dirty="0">
+                <a:latin typeface="Aptos" panose="020B0004020202020204" pitchFamily="34" charset="0"/>
+              </a:rPr>
+              <a:t>https://pageviews.wmcloud.org/ [4]  </a:t>
+            </a:r>
           </a:p>
         </p:txBody>
       </p:sp>
@@ -19218,7 +20281,7 @@
             <p:ph idx="1"/>
             <p:extLst>
               <p:ext uri="{D42A27DB-BD31-4B8C-83A1-F6EECF244321}">
-                <p14:modId xmlns:p14="http://schemas.microsoft.com/office/powerpoint/2010/main" val="3813927340"/>
+                <p14:modId xmlns:p14="http://schemas.microsoft.com/office/powerpoint/2010/main" val="3375241789"/>
               </p:ext>
             </p:extLst>
           </p:nvPr>
@@ -19322,6 +20385,51 @@
           </a:p>
           <a:p>
             <a:endParaRPr lang="pl-PL" dirty="0"/>
+          </a:p>
+        </p:txBody>
+      </p:sp>
+      <p:sp>
+        <p:nvSpPr>
+          <p:cNvPr id="5" name="pole tekstowe 4">
+            <a:extLst>
+              <a:ext uri="{FF2B5EF4-FFF2-40B4-BE49-F238E27FC236}">
+                <a16:creationId xmlns:a16="http://schemas.microsoft.com/office/drawing/2014/main" id="{CE784E70-FF9A-68BD-887E-BC2C1A63DE80}"/>
+              </a:ext>
+            </a:extLst>
+          </p:cNvPr>
+          <p:cNvSpPr txBox="1"/>
+          <p:nvPr/>
+        </p:nvSpPr>
+        <p:spPr>
+          <a:xfrm>
+            <a:off x="695325" y="6251109"/>
+            <a:ext cx="9568976" cy="276999"/>
+          </a:xfrm>
+          <a:prstGeom prst="rect">
+            <a:avLst/>
+          </a:prstGeom>
+          <a:noFill/>
+        </p:spPr>
+        <p:txBody>
+          <a:bodyPr wrap="square" rtlCol="0">
+            <a:spAutoFit/>
+          </a:bodyPr>
+          <a:lstStyle/>
+          <a:p>
+            <a:r>
+              <a:rPr lang="pl-PL" sz="1200" dirty="0">
+                <a:solidFill>
+                  <a:schemeClr val="tx2"/>
+                </a:solidFill>
+              </a:rPr>
+              <a:t>Na podstawie </a:t>
+            </a:r>
+            <a:r>
+              <a:rPr lang="pl-PL" sz="1200" dirty="0">
+                <a:latin typeface="Aptos" panose="020B0004020202020204" pitchFamily="34" charset="0"/>
+              </a:rPr>
+              <a:t>https://pageviews.wmcloud.org/ [4] </a:t>
+            </a:r>
           </a:p>
         </p:txBody>
       </p:sp>
@@ -19401,7 +20509,7 @@
             <p:ph idx="1"/>
             <p:extLst>
               <p:ext uri="{D42A27DB-BD31-4B8C-83A1-F6EECF244321}">
-                <p14:modId xmlns:p14="http://schemas.microsoft.com/office/powerpoint/2010/main" val="829675981"/>
+                <p14:modId xmlns:p14="http://schemas.microsoft.com/office/powerpoint/2010/main" val="2651078881"/>
               </p:ext>
             </p:extLst>
           </p:nvPr>
@@ -19712,6 +20820,51 @@
           </a:p>
         </p:txBody>
       </p:sp>
+      <p:sp>
+        <p:nvSpPr>
+          <p:cNvPr id="5" name="pole tekstowe 4">
+            <a:extLst>
+              <a:ext uri="{FF2B5EF4-FFF2-40B4-BE49-F238E27FC236}">
+                <a16:creationId xmlns:a16="http://schemas.microsoft.com/office/drawing/2014/main" id="{AC9DEECA-28D9-00F8-F31C-EB2CB9AC30EC}"/>
+              </a:ext>
+            </a:extLst>
+          </p:cNvPr>
+          <p:cNvSpPr txBox="1"/>
+          <p:nvPr/>
+        </p:nvSpPr>
+        <p:spPr>
+          <a:xfrm>
+            <a:off x="695325" y="6251109"/>
+            <a:ext cx="9568976" cy="276999"/>
+          </a:xfrm>
+          <a:prstGeom prst="rect">
+            <a:avLst/>
+          </a:prstGeom>
+          <a:noFill/>
+        </p:spPr>
+        <p:txBody>
+          <a:bodyPr wrap="square" rtlCol="0">
+            <a:spAutoFit/>
+          </a:bodyPr>
+          <a:lstStyle/>
+          <a:p>
+            <a:r>
+              <a:rPr lang="pl-PL" sz="1200" dirty="0">
+                <a:solidFill>
+                  <a:schemeClr val="tx2"/>
+                </a:solidFill>
+              </a:rPr>
+              <a:t>Na podstawie </a:t>
+            </a:r>
+            <a:r>
+              <a:rPr lang="pl-PL" sz="1200" dirty="0">
+                <a:latin typeface="Aptos" panose="020B0004020202020204" pitchFamily="34" charset="0"/>
+              </a:rPr>
+              <a:t>https://pageviews.wmcloud.org/ [4]  </a:t>
+            </a:r>
+          </a:p>
+        </p:txBody>
+      </p:sp>
     </p:spTree>
     <p:extLst>
       <p:ext uri="{BB962C8B-B14F-4D97-AF65-F5344CB8AC3E}">
@@ -19744,36 +20897,6 @@
       </p:grpSpPr>
       <p:sp>
         <p:nvSpPr>
-          <p:cNvPr id="2" name="Tytuł 1">
-            <a:extLst>
-              <a:ext uri="{FF2B5EF4-FFF2-40B4-BE49-F238E27FC236}">
-                <a16:creationId xmlns:a16="http://schemas.microsoft.com/office/drawing/2014/main" id="{9B06FA26-7517-0D14-088B-3B65931650DB}"/>
-              </a:ext>
-            </a:extLst>
-          </p:cNvPr>
-          <p:cNvSpPr>
-            <a:spLocks noGrp="1"/>
-          </p:cNvSpPr>
-          <p:nvPr>
-            <p:ph type="title"/>
-          </p:nvPr>
-        </p:nvSpPr>
-        <p:spPr/>
-        <p:txBody>
-          <a:bodyPr>
-            <a:noAutofit/>
-          </a:bodyPr>
-          <a:lstStyle/>
-          <a:p>
-            <a:r>
-              <a:rPr lang="pl-PL" dirty="0"/>
-              <a:t>Dlaczego otwieramy Wikipedię?</a:t>
-            </a:r>
-          </a:p>
-        </p:txBody>
-      </p:sp>
-      <p:sp>
-        <p:nvSpPr>
           <p:cNvPr id="3" name="Symbol zastępczy zawartości 2">
             <a:extLst>
               <a:ext uri="{FF2B5EF4-FFF2-40B4-BE49-F238E27FC236}">
@@ -19790,51 +20913,83 @@
         </p:nvSpPr>
         <p:spPr/>
         <p:txBody>
-          <a:bodyPr/>
+          <a:bodyPr>
+            <a:normAutofit/>
+          </a:bodyPr>
           <a:lstStyle/>
           <a:p>
-            <a:pPr marL="0" indent="0">
+            <a:pPr fontAlgn="t">
               <a:buNone/>
             </a:pPr>
-            <a:r>
-              <a:rPr lang="pl-PL" dirty="0">
-                <a:solidFill>
-                  <a:schemeClr val="tx2"/>
-                </a:solidFill>
-              </a:rPr>
-              <a:t>Analiza powyższych przykładów pokazuje, że Wikipedia nie jest tylko encyklopedią. </a:t>
-            </a:r>
+            <a:endParaRPr lang="pl-PL" sz="4000" dirty="0"/>
           </a:p>
           <a:p>
-            <a:pPr marL="0" indent="0">
+            <a:pPr fontAlgn="t">
               <a:buNone/>
             </a:pPr>
             <a:r>
-              <a:rPr lang="pl-PL" dirty="0">
-                <a:solidFill>
-                  <a:schemeClr val="tx2"/>
-                </a:solidFill>
-              </a:rPr>
-              <a:t>Jest miejscem do którego udajemy się, by zrozumieć świat wokół nas. By zgłębić wydarzenia wywołujące smutek, strach, ciekawość czy ekscytację.</a:t>
+              <a:rPr lang="pl-PL" sz="4000" dirty="0"/>
+              <a:t>Nie otwieramy Wikipedii tylko po wiedzę.</a:t>
             </a:r>
           </a:p>
           <a:p>
-            <a:pPr marL="0" indent="0">
+            <a:pPr marL="0" indent="0" fontAlgn="t">
               <a:buNone/>
             </a:pPr>
-            <a:endParaRPr lang="pl-PL" dirty="0"/>
+            <a:r>
+              <a:rPr lang="pl-PL" sz="4000" dirty="0"/>
+              <a:t>Otwieramy ją wtedy, gdy dzieje się coś ważnego.</a:t>
+            </a:r>
           </a:p>
           <a:p>
-            <a:pPr marL="0" indent="0">
+            <a:pPr fontAlgn="t">
               <a:buNone/>
             </a:pPr>
             <a:r>
-              <a:rPr lang="pl-PL" b="1" dirty="0"/>
-              <a:t>Wikipedia odpowiada na nasze emocje. Od 25 lat.</a:t>
+              <a:rPr lang="pl-PL" sz="4000" b="1" dirty="0">
+                <a:latin typeface="Montserrat" pitchFamily="2" charset="-18"/>
+              </a:rPr>
+              <a:t>Od 25 lat.</a:t>
             </a:r>
           </a:p>
         </p:txBody>
       </p:sp>
+      <p:pic>
+        <p:nvPicPr>
+          <p:cNvPr id="7" name="Obraz 6">
+            <a:extLst>
+              <a:ext uri="{FF2B5EF4-FFF2-40B4-BE49-F238E27FC236}">
+                <a16:creationId xmlns:a16="http://schemas.microsoft.com/office/drawing/2014/main" id="{C5AE2DDD-F83E-5B49-400C-A739A05D938B}"/>
+              </a:ext>
+            </a:extLst>
+          </p:cNvPr>
+          <p:cNvPicPr>
+            <a:picLocks noChangeAspect="1"/>
+          </p:cNvPicPr>
+          <p:nvPr/>
+        </p:nvPicPr>
+        <p:blipFill>
+          <a:blip r:embed="rId2">
+            <a:extLst>
+              <a:ext uri="{28A0092B-C50C-407E-A947-70E740481C1C}">
+                <a14:useLocalDpi xmlns:a14="http://schemas.microsoft.com/office/drawing/2010/main" val="0"/>
+              </a:ext>
+            </a:extLst>
+          </a:blip>
+          <a:stretch>
+            <a:fillRect/>
+          </a:stretch>
+        </p:blipFill>
+        <p:spPr>
+          <a:xfrm>
+            <a:off x="2843513" y="360196"/>
+            <a:ext cx="6504972" cy="992727"/>
+          </a:xfrm>
+          <a:prstGeom prst="rect">
+            <a:avLst/>
+          </a:prstGeom>
+        </p:spPr>
+      </p:pic>
     </p:spTree>
     <p:extLst>
       <p:ext uri="{BB962C8B-B14F-4D97-AF65-F5344CB8AC3E}">

</xml_diff>